<commit_message>
render: W21 tue (auto-published from production-dispatcher)
</commit_message>
<xml_diff>
--- a/W21-f4265b/tue/slides/04-strip-card-2.pptx
+++ b/W21-f4265b/tue/slides/04-strip-card-2.pptx
@@ -3096,33 +3096,9 @@
         <p:nvPr/>
       </p:nvGrpSpPr>
       <p:grpSpPr/>
-      <p:pic>
-        <p:nvPicPr>
-          <p:cNvPr id="2" name="Picture 1" descr="las-olas-value-literal-b739ac49.png"/>
-          <p:cNvPicPr>
-            <a:picLocks noChangeAspect="1"/>
-          </p:cNvPicPr>
-          <p:nvPr/>
-        </p:nvPicPr>
-        <p:blipFill>
-          <a:blip r:embed="rId2"/>
-          <a:stretch>
-            <a:fillRect/>
-          </a:stretch>
-        </p:blipFill>
-        <p:spPr>
-          <a:xfrm>
-            <a:off x="0" y="0"/>
-            <a:ext cx="10287000" cy="3619500"/>
-          </a:xfrm>
-          <a:prstGeom prst="rect">
-            <a:avLst/>
-          </a:prstGeom>
-        </p:spPr>
-      </p:pic>
-      <p:sp>
-        <p:nvSpPr>
-          <p:cNvPr id="3" name="TextBox 2"/>
+      <p:sp>
+        <p:nvSpPr>
+          <p:cNvPr id="2" name="TextBox 1"/>
           <p:cNvSpPr txBox="1"/>
           <p:nvPr/>
         </p:nvSpPr>
@@ -3156,7 +3132,7 @@
       </p:sp>
       <p:sp>
         <p:nvSpPr>
-          <p:cNvPr id="4" name="TextBox 3"/>
+          <p:cNvPr id="3" name="TextBox 2"/>
           <p:cNvSpPr txBox="1"/>
           <p:nvPr/>
         </p:nvSpPr>
@@ -3191,7 +3167,7 @@
       </p:sp>
       <p:sp>
         <p:nvSpPr>
-          <p:cNvPr id="5" name="TextBox 4"/>
+          <p:cNvPr id="4" name="TextBox 3"/>
           <p:cNvSpPr txBox="1"/>
           <p:nvPr/>
         </p:nvSpPr>
@@ -3225,7 +3201,7 @@
       </p:sp>
       <p:sp>
         <p:nvSpPr>
-          <p:cNvPr id="6" name="TextBox 5"/>
+          <p:cNvPr id="5" name="TextBox 4"/>
           <p:cNvSpPr txBox="1"/>
           <p:nvPr/>
         </p:nvSpPr>
@@ -3264,7 +3240,7 @@
       </p:sp>
       <p:sp>
         <p:nvSpPr>
-          <p:cNvPr id="7" name="TextBox 6"/>
+          <p:cNvPr id="6" name="TextBox 5"/>
           <p:cNvSpPr txBox="1"/>
           <p:nvPr/>
         </p:nvSpPr>
@@ -3298,7 +3274,7 @@
       </p:sp>
       <p:sp>
         <p:nvSpPr>
-          <p:cNvPr id="8" name="TextBox 7"/>
+          <p:cNvPr id="7" name="TextBox 6"/>
           <p:cNvSpPr txBox="1"/>
           <p:nvPr/>
         </p:nvSpPr>
@@ -3355,7 +3331,7 @@
       </p:sp>
       <p:sp>
         <p:nvSpPr>
-          <p:cNvPr id="9" name="TextBox 8"/>
+          <p:cNvPr id="8" name="TextBox 7"/>
           <p:cNvSpPr txBox="1"/>
           <p:nvPr/>
         </p:nvSpPr>
@@ -3389,7 +3365,7 @@
       </p:sp>
       <p:sp>
         <p:nvSpPr>
-          <p:cNvPr id="10" name="TextBox 9"/>
+          <p:cNvPr id="9" name="TextBox 8"/>
           <p:cNvSpPr txBox="1"/>
           <p:nvPr/>
         </p:nvSpPr>

</xml_diff>